<commit_message>
List presenters alphabetically by surname
Co-Authored-By: Claude Opus 5.5 <noreply@anthropic.com>
Claude-Session: https://claude.ai/code/session_01FMwTZ7R8TEiSepVQnx36Qp
</commit_message>
<xml_diff>
--- a/presentaciones/Tipos_de_Control_Administrativo.pptx
+++ b/presentaciones/Tipos_de_Control_Administrativo.pptx
@@ -130,42 +130,42 @@
   <p:extLst>
     <p:ext uri="{521415D9-36F7-43E2-AB2F-B90AF26B5E84}">
       <p14:sectionLst xmlns:p14="http://schemas.microsoft.com/office/powerpoint/2010/main">
-        <p14:section name="Portada" id="{3b98746b-2886-7957-e7a1-378d9e1408f0}">
+        <p14:section name="Portada" id="{755b1107-f145-89b2-f636-ef687e15911e}">
           <p14:sldIdLst>
             <p14:sldId id="256"/>
           </p14:sldIdLst>
         </p14:section>
-        <p14:section name="Introducción" id="{f7908ee2-76c9-7ce3-de39-0998963af744}">
+        <p14:section name="Introducción" id="{03075dcc-299a-530f-b875-8fd737d86a39}">
           <p14:sldIdLst>
             <p14:sldId id="257"/>
             <p14:sldId id="258"/>
           </p14:sldIdLst>
         </p14:section>
-        <p14:section name="Estándares de desempeño" id="{e79d2a40-119a-f166-641c-7e490cd09f65}">
+        <p14:section name="Estándares de desempeño" id="{5f960c0b-d596-87e1-72e5-4780e9e35309}">
           <p14:sldIdLst>
             <p14:sldId id="259"/>
             <p14:sldId id="260"/>
             <p14:sldId id="261"/>
           </p14:sldIdLst>
         </p14:section>
-        <p14:section name="Técnicas de planificación" id="{e1fa0420-8c13-9ce6-2a89-9e3c720c17ff}">
+        <p14:section name="Técnicas de planificación" id="{780d57f0-18ff-cf89-e7c1-af1e189e58f8}">
           <p14:sldIdLst>
             <p14:sldId id="262"/>
           </p14:sldIdLst>
         </p14:section>
-        <p14:section name="Benchmarking" id="{0c6f5287-64d0-125b-f83a-ccfa422852c3}">
+        <p14:section name="Benchmarking" id="{59efe9b0-d575-a8a7-3917-5fc723bf6c1a}">
           <p14:sldIdLst>
             <p14:sldId id="263"/>
             <p14:sldId id="264"/>
           </p14:sldIdLst>
         </p14:section>
-        <p14:section name="Diagrama de Gantt" id="{42d0d24f-0394-1cde-fe13-1071be774192}">
+        <p14:section name="Diagrama de Gantt" id="{a6e93279-9b3b-edde-7be2-78e17a07298d}">
           <p14:sldIdLst>
             <p14:sldId id="265"/>
             <p14:sldId id="266"/>
           </p14:sldIdLst>
         </p14:section>
-        <p14:section name="Técnica PERT" id="{6a57e47c-62b5-e32a-081a-3ad18b1ba301}">
+        <p14:section name="Técnica PERT" id="{bfa4d86f-49b0-171c-b0e8-26c2951b05e2}">
           <p14:sldIdLst>
             <p14:sldId id="267"/>
             <p14:sldId id="268"/>
@@ -176,14 +176,14 @@
             <p14:sldId id="273"/>
           </p14:sldIdLst>
         </p14:section>
-        <p14:section name="Método de la ruta crítica" id="{48a09358-7096-248b-8d1b-8da184ef843c}">
+        <p14:section name="Método de la ruta crítica" id="{41108fcb-322e-5dc6-e64d-d0acf4495445}">
           <p14:sldIdLst>
             <p14:sldId id="274"/>
             <p14:sldId id="275"/>
             <p14:sldId id="276"/>
           </p14:sldIdLst>
         </p14:section>
-        <p14:section name="Conclusión" id="{8d9afe37-3a7a-0f9c-54ed-7c956667e098}">
+        <p14:section name="Conclusión" id="{7229924f-6fd6-3f9b-729f-c38e9290c9ff}">
           <p14:sldIdLst>
             <p14:sldId id="277"/>
             <p14:sldId id="278"/>
@@ -3515,7 +3515,7 @@
                   <a:schemeClr val="bg2"/>
                 </a:solidFill>
               </a:rPr>
-              <a:t>Yadiel Cruz · Joan Rios · Alayla Arbonies · Suheily Ramos · Niguel Morris-Santiago · Suheil Collazo</a:t>
+              <a:t>Alayla Arbonies · Suheil Collazo · Yadiel Cruz · Niguel Morris-Santiago · Suheily Ramos · Joan Rios</a:t>
             </a:r>
             <a:endParaRPr lang="en-US" sz="1300" dirty="0"/>
           </a:p>
@@ -16085,7 +16085,7 @@
                   <a:schemeClr val="bg2"/>
                 </a:solidFill>
               </a:rPr>
-              <a:t>Yadiel Cruz · Joan Rios · Alayla Arbonies · Suheily Ramos · Niguel Morris-Santiago · Suheil Collazo</a:t>
+              <a:t>Alayla Arbonies · Suheil Collazo · Yadiel Cruz · Niguel Morris-Santiago · Suheily Ramos · Joan Rios</a:t>
             </a:r>
             <a:endParaRPr lang="en-US" sz="1300" dirty="0"/>
           </a:p>

</xml_diff>